<commit_message>
Rebuild the code-walk deck for the work_dir change
Four lines of slide text change:
  - slide 1: the head commit and the test count (154)
  - slide 9: the make_engine_bounded snippet now shows work_dir
  - slide 15: the test count
run.json was re-mined first, as build_deck.js asks. Beyond the counts, it moves only the
mock campaign's node-id suffix; the metrics are identical.

The PDF step was undocumented, and neither tool is installed on Delta, so build_deck.js
now says how to run it. Node comes from `pixi exec`, and LibreOffice from the
linuxserver/libreoffice image under apptainer. The fonts are pinned: the container
prefers Noto, so Calibri, Cambria and Consolas are aliased to DejaVu Sans, Serif and
Sans Mono, which is what the first PDF was rendered with.

Co-Authored-By: Claude Opus 5.5 <noreply@anthropic.com>
</commit_message>
<xml_diff>
--- a/slides/impress-a-codewalk.pptx
+++ b/slides/impress-a-codewalk.pptx
@@ -3466,7 +3466,7 @@
                 <a:ea typeface="Calibri" pitchFamily="34" charset="-122"/>
                 <a:cs typeface="Calibri" pitchFamily="34" charset="-120"/>
               </a:rPr>
-              <a:t>Lab code walk · main @ 3e64ba6 · 6.5k lines of source, 152 tests, 11 tools in 5 toolkits</a:t>
+              <a:t>Lab code walk · main @ 79e539f · 6.5k lines of source, 154 tests, 11 tools in 5 toolkits</a:t>
             </a:r>
             <a:endParaRPr lang="en-US" sz="1200" dirty="0"/>
           </a:p>
@@ -14036,7 +14036,7 @@
                 <a:ea typeface="Consolas" pitchFamily="34" charset="-122"/>
                 <a:cs typeface="Consolas" pitchFamily="34" charset="-120"/>
               </a:rPr>
-              <a:t>pytest tests -q                    # 152 tests, no allocation</a:t>
+              <a:t>pytest tests -q                    # 154 tests, no allocation</a:t>
             </a:r>
             <a:endParaRPr lang="en-US" sz="1000" dirty="0"/>
           </a:p>
@@ -36254,7 +36254,7 @@
                 <a:ea typeface="Consolas" pitchFamily="34" charset="-122"/>
                 <a:cs typeface="Consolas" pitchFamily="34" charset="-120"/>
               </a:rPr>
-              <a:t>async def make_engine_bounded(kind, config, timeout_s, heartbeat_s):</a:t>
+              <a:t>async def make_engine_bounded(kind, config, timeout_s, heartbeat_s, work_dir):</a:t>
             </a:r>
             <a:endParaRPr lang="en-US" sz="792" dirty="0"/>
           </a:p>
@@ -36452,7 +36452,7 @@
                 <a:ea typeface="Consolas" pitchFamily="34" charset="-122"/>
                 <a:cs typeface="Consolas" pitchFamily="34" charset="-120"/>
               </a:rPr>
-              <a:t>        return await WorkflowEngine.create(backend=backend), backend</a:t>
+              <a:t>        return await WorkflowEngine.create(backend=backend, work_dir=work_dir), backend</a:t>
             </a:r>
             <a:endParaRPr lang="en-US" sz="792" dirty="0"/>
           </a:p>

</xml_diff>

<commit_message>
Rebuild the deck for integrity-only trust, and let slide 6 tell its own story
Slides 3 and 7 now say promotion counts integrity-clean runs and that only an
integrity failure demotes. The admission speaker note says what clean means, and
why the Delta trust run promoted nothing.

Slide 6 is mined from a live mock run, but its trust clause was hard-coded as
"the third clean run promoted it". The reseeded mock reaches the front target after
two clean runs, before any promotion, so the card now follows run.json either way.
The speaker note no longer recites counts that a reseed can change.

Also moves the spec.py anchor (106 -> 107), and re-mines run.json for the test
count (162). The PDF is rendered as in the build_deck.js header, with DejaVu
pinned. Slides 3, 6 and 7 were checked visually for overflow.

Co-Authored-By: Claude Opus 5.5 <noreply@anthropic.com>
</commit_message>
<xml_diff>
--- a/slides/impress-a-codewalk.pptx
+++ b/slides/impress-a-codewalk.pptx
@@ -1899,8 +1899,8 @@
               <a:rPr lang="en-US" dirty="0"/>
               <a:t>[1:00] One experiment, left to right, naming the type at each hop — the types are the contract between layers.
 The executor builds an observation. The policy returns a decision carrying an experiment intent: tool ids, parameters, a replica count. It is abstract, there is no DAG in it. The composer turns it into a typed graph, which is plain data. Dispatch registers that graph and hands back a handle without awaiting. What comes back is a run outcome, serializable and core-typed, so a reasoner in another process can hold it.
-Underneath is an actual run on this laptop. Four admissions over three cycles. The first row was refused by the interlock — a provisional pattern is capped at ten percent of available budget and three lineages did not fit. The policy shrank to two and resubmitted. That is the retry doing its job: a refusal costs an attempt, not the experiment.
-Six design nodes, every one marked suspect, because the shape stayed provisional until the third clean run promoted it.</a:t>
+Underneath is an actual run on this laptop. The first row was refused by the interlock — a provisional pattern is capped at ten percent of available budget and three lineages did not fit. The policy shrank to two and resubmitted. That is the retry doing its job: a refusal costs an attempt, not the experiment.
+Every design node is marked suspect, because the shape is provisional while it runs. Promotion takes three clean runs, and the card on the right says whether this one got there before the front target stopped it.</a:t>
             </a:r>
             <a:endParaRPr lang="en-US" dirty="0"/>
           </a:p>
@@ -1992,7 +1992,7 @@
 Five gates, in order, first refusal wins. Gate two rejects a tool composed without its QC gates, so you cannot compose your way out of quality control. Gate four rejects a P6 tool somebody tried to schedule — those are meant to be inlined, and a scheduled one is a composer bug.
 Then three things that are not gates. The interlock. A dry-run, where every agent parameterizes without executing — that catches a graph that type-checks but cannot be turned into a command line. And a reservation.
 Reserve is last for a reason: the dry-run awaits, and by the time it returns another submission may have claimed the budget gate five saw. Reserve re-checks against available budget and is the authoritative decision.
-On the right, the trust half. A pattern is the graph's shape — tool ids and typed edges, hashed, parameter values deliberately excluded so tuning a parameter does not reset trust. A provisional shape is capped, forced through a dry-run, marked suspect whatever it scores, and may have only one instance in flight, because promotion counts consecutive clean runs and N concurrent copies are one draw sampled N times.
+On the right, the trust half. A pattern is the graph's shape — tool ids and typed edges, hashed, parameter values deliberately excluded so tuning a parameter does not reset trust. A provisional shape is capped, forced through a dry-run, marked suspect whatever it scores, and may have only one instance in flight, because promotion counts consecutive clean runs and N concurrent copies are one draw sampled N times. Clean means no integrity gate failed: the tool ran and reported real numbers. A design that merely scores below a quality threshold still fails its node, but it is not evidence against the shape. Counting it was why our five-cycle trust run on Delta promoted nothing.
 The limit, from our own limitations doc: this buys examination and delay, not soundness. A consistent novel silent failure promotes.</a:t>
             </a:r>
             <a:endParaRPr lang="en-US" dirty="0"/>
@@ -3466,7 +3466,7 @@
                 <a:ea typeface="Calibri" pitchFamily="34" charset="-122"/>
                 <a:cs typeface="Calibri" pitchFamily="34" charset="-120"/>
               </a:rPr>
-              <a:t>Lab code walk · main @ 79e539f · 6.5k lines of source, 154 tests, 11 tools in 5 toolkits</a:t>
+              <a:t>Lab code walk · main @ 7acce29 · 6.5k lines of source, 162 tests, 11 tools in 5 toolkits</a:t>
             </a:r>
             <a:endParaRPr lang="en-US" sz="1200" dirty="0"/>
           </a:p>
@@ -8097,7 +8097,7 @@
                 <a:ea typeface="Consolas" pitchFamily="34" charset="-122"/>
                 <a:cs typeface="Consolas" pitchFamily="34" charset="-120"/>
               </a:rPr>
-              <a:t>composer.py:45 · validate.py:106 · spec.py:106  ·  EDITED — @property elided</a:t>
+              <a:t>composer.py:45 · validate.py:106 · spec.py:107  ·  EDITED — @property elided</a:t>
             </a:r>
             <a:endParaRPr lang="en-US" sz="850" dirty="0"/>
           </a:p>
@@ -14036,7 +14036,7 @@
                 <a:ea typeface="Consolas" pitchFamily="34" charset="-122"/>
                 <a:cs typeface="Consolas" pitchFamily="34" charset="-120"/>
               </a:rPr>
-              <a:t>pytest tests -q                    # 154 tests, no allocation</a:t>
+              <a:t>pytest tests -q                    # 162 tests, no allocation</a:t>
             </a:r>
             <a:endParaRPr lang="en-US" sz="1000" dirty="0"/>
           </a:p>
@@ -23776,7 +23776,7 @@
                           <a:ea typeface="Calibri" pitchFamily="34" charset="-122"/>
                           <a:cs typeface="Calibri" pitchFamily="34" charset="-120"/>
                         </a:rPr>
-                        <a:t>A novel graph shape runs under a cost cap, a forced dry-run, and is marked suspect whatever it scores. Promotion is N consecutive clean runs; demotion is immediate.</a:t>
+                        <a:t>A novel graph shape runs under a cost cap, a forced dry-run, and is marked suspect whatever it scores. Promotion is N consecutive integrity-clean runs; demotion is immediate.</a:t>
                       </a:r>
                       <a:endParaRPr lang="en-US" sz="1150" dirty="0">
                         <a:latin typeface="Calibri" charset="0"/>
@@ -29069,7 +29069,7 @@
                 <a:ea typeface="Consolas" pitchFamily="34" charset="-122"/>
                 <a:cs typeface="Consolas" pitchFamily="34" charset="-120"/>
               </a:rPr>
-              <a:t>  cycles   : 3</a:t>
+              <a:t>  cycles   : 2</a:t>
             </a:r>
             <a:endParaRPr lang="en-US" sz="1000" dirty="0"/>
           </a:p>
@@ -29109,7 +29109,7 @@
                 <a:ea typeface="Consolas" pitchFamily="34" charset="-122"/>
                 <a:cs typeface="Consolas" pitchFamily="34" charset="-120"/>
               </a:rPr>
-              <a:t>  nodes    : 6  front: 4</a:t>
+              <a:t>  nodes    : 4  front: 3</a:t>
             </a:r>
             <a:endParaRPr lang="en-US" sz="1000" dirty="0"/>
           </a:p>
@@ -30551,348 +30551,6 @@
                   </a:tcPr>
                 </a:tc>
               </a:tr>
-              <a:tr h="274320">
-                <a:tc>
-                  <a:txBody>
-                    <a:bodyPr/>
-                    <a:lstStyle/>
-                    <a:p>
-                      <a:pPr algn="l" indent="0" marL="0">
-                        <a:buNone/>
-                      </a:pPr>
-                      <a:r>
-                        <a:rPr lang="en-US" sz="1050" b="1" dirty="0">
-                          <a:solidFill>
-                            <a:srgbClr val="22303C"/>
-                          </a:solidFill>
-                          <a:latin typeface="Calibri" pitchFamily="34" charset="0"/>
-                          <a:ea typeface="Calibri" pitchFamily="34" charset="-122"/>
-                          <a:cs typeface="Calibri" pitchFamily="34" charset="-120"/>
-                        </a:rPr>
-                        <a:t>r0004</a:t>
-                      </a:r>
-                      <a:endParaRPr lang="en-US" sz="1050" dirty="0">
-                        <a:latin typeface="Calibri" charset="0"/>
-                        <a:ea typeface="Calibri" charset="0"/>
-                        <a:cs typeface="Calibri" charset="0"/>
-                      </a:endParaRPr>
-                    </a:p>
-                  </a:txBody>
-                  <a:tcPr marL="64008" marR="64008" marT="64008" marB="64008" anchor="ctr">
-                    <a:lnL w="9525" cap="flat" cmpd="sng" algn="ctr">
-                      <a:solidFill>
-                        <a:srgbClr val="C9D1D8"/>
-                      </a:solidFill>
-                      <a:prstDash val="solid"/>
-                      <a:round/>
-                      <a:headEnd type="none" w="med" len="med"/>
-                      <a:tailEnd type="none" w="med" len="med"/>
-                    </a:lnL>
-                    <a:lnR w="9525" cap="flat" cmpd="sng" algn="ctr">
-                      <a:solidFill>
-                        <a:srgbClr val="C9D1D8"/>
-                      </a:solidFill>
-                      <a:prstDash val="solid"/>
-                      <a:round/>
-                      <a:headEnd type="none" w="med" len="med"/>
-                      <a:tailEnd type="none" w="med" len="med"/>
-                    </a:lnR>
-                    <a:lnT w="9525" cap="flat" cmpd="sng" algn="ctr">
-                      <a:solidFill>
-                        <a:srgbClr val="C9D1D8"/>
-                      </a:solidFill>
-                      <a:prstDash val="solid"/>
-                      <a:round/>
-                      <a:headEnd type="none" w="med" len="med"/>
-                      <a:tailEnd type="none" w="med" len="med"/>
-                    </a:lnT>
-                    <a:lnB w="9525" cap="flat" cmpd="sng" algn="ctr">
-                      <a:solidFill>
-                        <a:srgbClr val="C9D1D8"/>
-                      </a:solidFill>
-                      <a:prstDash val="solid"/>
-                      <a:round/>
-                      <a:headEnd type="none" w="med" len="med"/>
-                      <a:tailEnd type="none" w="med" len="med"/>
-                    </a:lnB>
-                    <a:solidFill>
-                      <a:srgbClr val="FFFFFF"/>
-                    </a:solidFill>
-                  </a:tcPr>
-                </a:tc>
-                <a:tc>
-                  <a:txBody>
-                    <a:bodyPr/>
-                    <a:lstStyle/>
-                    <a:p>
-                      <a:pPr algn="l" indent="0" marL="0">
-                        <a:buNone/>
-                      </a:pPr>
-                      <a:r>
-                        <a:rPr lang="en-US" sz="950" dirty="0">
-                          <a:solidFill>
-                            <a:srgbClr val="5E6B75"/>
-                          </a:solidFill>
-                          <a:latin typeface="Consolas" pitchFamily="34" charset="0"/>
-                          <a:ea typeface="Consolas" pitchFamily="34" charset="-122"/>
-                          <a:cs typeface="Consolas" pitchFamily="34" charset="-120"/>
-                        </a:rPr>
-                        <a:t>66bb4923…</a:t>
-                      </a:r>
-                      <a:endParaRPr lang="en-US" sz="950" dirty="0">
-                        <a:latin typeface="Consolas" charset="0"/>
-                        <a:ea typeface="Consolas" charset="0"/>
-                        <a:cs typeface="Consolas" charset="0"/>
-                      </a:endParaRPr>
-                    </a:p>
-                  </a:txBody>
-                  <a:tcPr marL="64008" marR="64008" marT="64008" marB="64008" anchor="ctr">
-                    <a:lnL w="9525" cap="flat" cmpd="sng" algn="ctr">
-                      <a:solidFill>
-                        <a:srgbClr val="C9D1D8"/>
-                      </a:solidFill>
-                      <a:prstDash val="solid"/>
-                      <a:round/>
-                      <a:headEnd type="none" w="med" len="med"/>
-                      <a:tailEnd type="none" w="med" len="med"/>
-                    </a:lnL>
-                    <a:lnR w="9525" cap="flat" cmpd="sng" algn="ctr">
-                      <a:solidFill>
-                        <a:srgbClr val="C9D1D8"/>
-                      </a:solidFill>
-                      <a:prstDash val="solid"/>
-                      <a:round/>
-                      <a:headEnd type="none" w="med" len="med"/>
-                      <a:tailEnd type="none" w="med" len="med"/>
-                    </a:lnR>
-                    <a:lnT w="9525" cap="flat" cmpd="sng" algn="ctr">
-                      <a:solidFill>
-                        <a:srgbClr val="C9D1D8"/>
-                      </a:solidFill>
-                      <a:prstDash val="solid"/>
-                      <a:round/>
-                      <a:headEnd type="none" w="med" len="med"/>
-                      <a:tailEnd type="none" w="med" len="med"/>
-                    </a:lnT>
-                    <a:lnB w="9525" cap="flat" cmpd="sng" algn="ctr">
-                      <a:solidFill>
-                        <a:srgbClr val="C9D1D8"/>
-                      </a:solidFill>
-                      <a:prstDash val="solid"/>
-                      <a:round/>
-                      <a:headEnd type="none" w="med" len="med"/>
-                      <a:tailEnd type="none" w="med" len="med"/>
-                    </a:lnB>
-                    <a:solidFill>
-                      <a:srgbClr val="FFFFFF"/>
-                    </a:solidFill>
-                  </a:tcPr>
-                </a:tc>
-                <a:tc>
-                  <a:txBody>
-                    <a:bodyPr/>
-                    <a:lstStyle/>
-                    <a:p>
-                      <a:pPr algn="ctr" indent="0" marL="0">
-                        <a:buNone/>
-                      </a:pPr>
-                      <a:r>
-                        <a:rPr lang="en-US" sz="1050" dirty="0">
-                          <a:solidFill>
-                            <a:srgbClr val="22303C"/>
-                          </a:solidFill>
-                          <a:latin typeface="Calibri" pitchFamily="34" charset="0"/>
-                          <a:ea typeface="Calibri" pitchFamily="34" charset="-122"/>
-                          <a:cs typeface="Calibri" pitchFamily="34" charset="-120"/>
-                        </a:rPr>
-                        <a:t>8</a:t>
-                      </a:r>
-                      <a:endParaRPr lang="en-US" sz="1050" dirty="0">
-                        <a:latin typeface="Calibri" charset="0"/>
-                        <a:ea typeface="Calibri" charset="0"/>
-                        <a:cs typeface="Calibri" charset="0"/>
-                      </a:endParaRPr>
-                    </a:p>
-                  </a:txBody>
-                  <a:tcPr marL="64008" marR="64008" marT="64008" marB="64008" anchor="ctr">
-                    <a:lnL w="9525" cap="flat" cmpd="sng" algn="ctr">
-                      <a:solidFill>
-                        <a:srgbClr val="C9D1D8"/>
-                      </a:solidFill>
-                      <a:prstDash val="solid"/>
-                      <a:round/>
-                      <a:headEnd type="none" w="med" len="med"/>
-                      <a:tailEnd type="none" w="med" len="med"/>
-                    </a:lnL>
-                    <a:lnR w="9525" cap="flat" cmpd="sng" algn="ctr">
-                      <a:solidFill>
-                        <a:srgbClr val="C9D1D8"/>
-                      </a:solidFill>
-                      <a:prstDash val="solid"/>
-                      <a:round/>
-                      <a:headEnd type="none" w="med" len="med"/>
-                      <a:tailEnd type="none" w="med" len="med"/>
-                    </a:lnR>
-                    <a:lnT w="9525" cap="flat" cmpd="sng" algn="ctr">
-                      <a:solidFill>
-                        <a:srgbClr val="C9D1D8"/>
-                      </a:solidFill>
-                      <a:prstDash val="solid"/>
-                      <a:round/>
-                      <a:headEnd type="none" w="med" len="med"/>
-                      <a:tailEnd type="none" w="med" len="med"/>
-                    </a:lnT>
-                    <a:lnB w="9525" cap="flat" cmpd="sng" algn="ctr">
-                      <a:solidFill>
-                        <a:srgbClr val="C9D1D8"/>
-                      </a:solidFill>
-                      <a:prstDash val="solid"/>
-                      <a:round/>
-                      <a:headEnd type="none" w="med" len="med"/>
-                      <a:tailEnd type="none" w="med" len="med"/>
-                    </a:lnB>
-                    <a:solidFill>
-                      <a:srgbClr val="FFFFFF"/>
-                    </a:solidFill>
-                  </a:tcPr>
-                </a:tc>
-                <a:tc>
-                  <a:txBody>
-                    <a:bodyPr/>
-                    <a:lstStyle/>
-                    <a:p>
-                      <a:pPr algn="ctr" indent="0" marL="0">
-                        <a:buNone/>
-                      </a:pPr>
-                      <a:r>
-                        <a:rPr lang="en-US" sz="1050" dirty="0">
-                          <a:solidFill>
-                            <a:srgbClr val="22303C"/>
-                          </a:solidFill>
-                          <a:latin typeface="Calibri" pitchFamily="34" charset="0"/>
-                          <a:ea typeface="Calibri" pitchFamily="34" charset="-122"/>
-                          <a:cs typeface="Calibri" pitchFamily="34" charset="-120"/>
-                        </a:rPr>
-                        <a:t>0.110</a:t>
-                      </a:r>
-                      <a:endParaRPr lang="en-US" sz="1050" dirty="0">
-                        <a:latin typeface="Calibri" charset="0"/>
-                        <a:ea typeface="Calibri" charset="0"/>
-                        <a:cs typeface="Calibri" charset="0"/>
-                      </a:endParaRPr>
-                    </a:p>
-                  </a:txBody>
-                  <a:tcPr marL="64008" marR="64008" marT="64008" marB="64008" anchor="ctr">
-                    <a:lnL w="9525" cap="flat" cmpd="sng" algn="ctr">
-                      <a:solidFill>
-                        <a:srgbClr val="C9D1D8"/>
-                      </a:solidFill>
-                      <a:prstDash val="solid"/>
-                      <a:round/>
-                      <a:headEnd type="none" w="med" len="med"/>
-                      <a:tailEnd type="none" w="med" len="med"/>
-                    </a:lnL>
-                    <a:lnR w="9525" cap="flat" cmpd="sng" algn="ctr">
-                      <a:solidFill>
-                        <a:srgbClr val="C9D1D8"/>
-                      </a:solidFill>
-                      <a:prstDash val="solid"/>
-                      <a:round/>
-                      <a:headEnd type="none" w="med" len="med"/>
-                      <a:tailEnd type="none" w="med" len="med"/>
-                    </a:lnR>
-                    <a:lnT w="9525" cap="flat" cmpd="sng" algn="ctr">
-                      <a:solidFill>
-                        <a:srgbClr val="C9D1D8"/>
-                      </a:solidFill>
-                      <a:prstDash val="solid"/>
-                      <a:round/>
-                      <a:headEnd type="none" w="med" len="med"/>
-                      <a:tailEnd type="none" w="med" len="med"/>
-                    </a:lnT>
-                    <a:lnB w="9525" cap="flat" cmpd="sng" algn="ctr">
-                      <a:solidFill>
-                        <a:srgbClr val="C9D1D8"/>
-                      </a:solidFill>
-                      <a:prstDash val="solid"/>
-                      <a:round/>
-                      <a:headEnd type="none" w="med" len="med"/>
-                      <a:tailEnd type="none" w="med" len="med"/>
-                    </a:lnB>
-                    <a:solidFill>
-                      <a:srgbClr val="FFFFFF"/>
-                    </a:solidFill>
-                  </a:tcPr>
-                </a:tc>
-                <a:tc>
-                  <a:txBody>
-                    <a:bodyPr/>
-                    <a:lstStyle/>
-                    <a:p>
-                      <a:pPr algn="l" indent="0" marL="0">
-                        <a:buNone/>
-                      </a:pPr>
-                      <a:r>
-                        <a:rPr lang="en-US" sz="1050" dirty="0">
-                          <a:solidFill>
-                            <a:srgbClr val="2E7D4F"/>
-                          </a:solidFill>
-                          <a:latin typeface="Calibri" pitchFamily="34" charset="0"/>
-                          <a:ea typeface="Calibri" pitchFamily="34" charset="-122"/>
-                          <a:cs typeface="Calibri" pitchFamily="34" charset="-120"/>
-                        </a:rPr>
-                        <a:t>yes</a:t>
-                      </a:r>
-                      <a:endParaRPr lang="en-US" sz="1050" dirty="0">
-                        <a:latin typeface="Calibri" charset="0"/>
-                        <a:ea typeface="Calibri" charset="0"/>
-                        <a:cs typeface="Calibri" charset="0"/>
-                      </a:endParaRPr>
-                    </a:p>
-                  </a:txBody>
-                  <a:tcPr marL="64008" marR="64008" marT="64008" marB="64008" anchor="ctr">
-                    <a:lnL w="9525" cap="flat" cmpd="sng" algn="ctr">
-                      <a:solidFill>
-                        <a:srgbClr val="C9D1D8"/>
-                      </a:solidFill>
-                      <a:prstDash val="solid"/>
-                      <a:round/>
-                      <a:headEnd type="none" w="med" len="med"/>
-                      <a:tailEnd type="none" w="med" len="med"/>
-                    </a:lnL>
-                    <a:lnR w="9525" cap="flat" cmpd="sng" algn="ctr">
-                      <a:solidFill>
-                        <a:srgbClr val="C9D1D8"/>
-                      </a:solidFill>
-                      <a:prstDash val="solid"/>
-                      <a:round/>
-                      <a:headEnd type="none" w="med" len="med"/>
-                      <a:tailEnd type="none" w="med" len="med"/>
-                    </a:lnR>
-                    <a:lnT w="9525" cap="flat" cmpd="sng" algn="ctr">
-                      <a:solidFill>
-                        <a:srgbClr val="C9D1D8"/>
-                      </a:solidFill>
-                      <a:prstDash val="solid"/>
-                      <a:round/>
-                      <a:headEnd type="none" w="med" len="med"/>
-                      <a:tailEnd type="none" w="med" len="med"/>
-                    </a:lnT>
-                    <a:lnB w="9525" cap="flat" cmpd="sng" algn="ctr">
-                      <a:solidFill>
-                        <a:srgbClr val="C9D1D8"/>
-                      </a:solidFill>
-                      <a:prstDash val="solid"/>
-                      <a:round/>
-                      <a:headEnd type="none" w="med" len="med"/>
-                      <a:tailEnd type="none" w="med" len="med"/>
-                    </a:lnB>
-                    <a:solidFill>
-                      <a:srgbClr val="FFFFFF"/>
-                    </a:solidFill>
-                  </a:tcPr>
-                </a:tc>
-              </a:tr>
             </a:tbl>
           </a:graphicData>
         </a:graphic>
@@ -31126,7 +30784,7 @@
                 <a:ea typeface="Calibri" pitchFamily="34" charset="-122"/>
                 <a:cs typeface="Calibri" pitchFamily="34" charset="-120"/>
               </a:rPr>
-              <a:t>6 design nodes over 3 cycles, every one marked suspect — the pattern was provisional until the third clean run promoted it (1 promotion, in trust_events).</a:t>
+              <a:t>4 design nodes over 2 cycles, every one marked suspect — the pattern stayed provisional: the front target was met after two clean runs, before the third that would promote it.</a:t>
             </a:r>
             <a:endParaRPr lang="en-US" sz="1050" dirty="0"/>
           </a:p>
@@ -31147,7 +30805,7 @@
                 <a:ea typeface="Calibri" pitchFamily="34" charset="-122"/>
                 <a:cs typeface="Calibri" pitchFamily="34" charset="-120"/>
               </a:rPr>
-              <a:t>Front of 4; the campaign stopped on "target front size 3 reached" rather than on budget.</a:t>
+              <a:t>Front of 3; the campaign stopped on "target front size 3 reached" rather than on budget.</a:t>
             </a:r>
             <a:endParaRPr lang="en-US" sz="1050" dirty="0"/>
           </a:p>
@@ -34735,7 +34393,7 @@
                 <a:ea typeface="Calibri" pitchFamily="34" charset="-122"/>
                 <a:cs typeface="Calibri" pitchFamily="34" charset="-120"/>
               </a:rPr>
-              <a:t>N consecutive clean runs promote; any failure demotes immediately and resets the counter.</a:t>
+              <a:t>N consecutive integrity-clean runs promote; any integrity failure demotes and resets the counter.</a:t>
             </a:r>
             <a:endParaRPr lang="en-US" sz="1000" dirty="0"/>
           </a:p>

</xml_diff>